<commit_message>
Add story template and initial HTML structure for HR-X presentation
</commit_message>
<xml_diff>
--- a/doc/HRX_dirigeants.pptx
+++ b/doc/HRX_dirigeants.pptx
@@ -5,15 +5,16 @@
     <p:sldMasterId id="2147483648" r:id="rId1"/>
   </p:sldMasterIdLst>
   <p:notesMasterIdLst>
-    <p:notesMasterId r:id="rId8"/>
+    <p:notesMasterId r:id="rId9"/>
   </p:notesMasterIdLst>
   <p:sldIdLst>
     <p:sldId id="256" r:id="rId2"/>
     <p:sldId id="257" r:id="rId3"/>
-    <p:sldId id="258" r:id="rId4"/>
-    <p:sldId id="259" r:id="rId5"/>
-    <p:sldId id="260" r:id="rId6"/>
-    <p:sldId id="261" r:id="rId7"/>
+    <p:sldId id="262" r:id="rId4"/>
+    <p:sldId id="258" r:id="rId5"/>
+    <p:sldId id="259" r:id="rId6"/>
+    <p:sldId id="260" r:id="rId7"/>
+    <p:sldId id="261" r:id="rId8"/>
   </p:sldIdLst>
   <p:sldSz cx="12192000" cy="6858000"/>
   <p:notesSz cx="6858000" cy="12192000"/>
@@ -199,7 +200,7 @@
           <a:p>
             <a:fld id="{5282F153-3F37-0F45-9E97-73ACFA13230C}" type="datetimeFigureOut">
               <a:rPr lang="en-US"/>
-              <a:t>6/17/2026</a:t>
+              <a:t>7/26/2026</a:t>
             </a:fld>
             <a:endParaRPr lang="en-US"/>
           </a:p>
@@ -808,7 +809,7 @@
           <a:p>
             <a:fld id="{F7021451-1387-4CA6-816F-3879F97B5CBC}" type="slidenum">
               <a:rPr lang="en-US"/>
-              <a:t>3</a:t>
+              <a:t>4</a:t>
             </a:fld>
             <a:endParaRPr lang="en-US"/>
           </a:p>
@@ -1044,7 +1045,7 @@
           <a:p>
             <a:fld id="{F7021451-1387-4CA6-816F-3879F97B5CBC}" type="slidenum">
               <a:rPr lang="en-US"/>
-              <a:t>4</a:t>
+              <a:t>5</a:t>
             </a:fld>
             <a:endParaRPr lang="en-US"/>
           </a:p>
@@ -1507,7 +1508,7 @@
           <a:p>
             <a:fld id="{F7021451-1387-4CA6-816F-3879F97B5CBC}" type="slidenum">
               <a:rPr lang="en-US"/>
-              <a:t>5</a:t>
+              <a:t>6</a:t>
             </a:fld>
             <a:endParaRPr lang="en-US"/>
           </a:p>
@@ -1591,7 +1592,7 @@
           <a:p>
             <a:fld id="{F7021451-1387-4CA6-816F-3879F97B5CBC}" type="slidenum">
               <a:rPr lang="en-US"/>
-              <a:t>6</a:t>
+              <a:t>7</a:t>
             </a:fld>
             <a:endParaRPr lang="en-US"/>
           </a:p>
@@ -1954,7 +1955,7 @@
       </p:grpSpPr>
       <p:pic>
         <p:nvPicPr>
-          <p:cNvPr id="2" name="Image 0" descr="/agent/turn2/workspace/images/image-aa1ac7c771e3dc45a2f1378847368f12.jpg"/>
+          <p:cNvPr id="2" name="Image 0"/>
           <p:cNvPicPr>
             <a:picLocks noChangeAspect="1"/>
           </p:cNvPicPr>
@@ -2417,23 +2418,14 @@
                             </p:childTnLst>
                           </p:cTn>
                         </p:par>
-                      </p:childTnLst>
-                    </p:cTn>
-                  </p:par>
-                  <p:par>
-                    <p:cTn id="7" fill="hold">
-                      <p:stCondLst>
-                        <p:cond delay="indefinite"/>
-                      </p:stCondLst>
-                      <p:childTnLst>
                         <p:par>
-                          <p:cTn id="8" fill="hold">
+                          <p:cTn id="7" fill="hold">
                             <p:stCondLst>
                               <p:cond delay="0"/>
                             </p:stCondLst>
                             <p:childTnLst>
                               <p:par>
-                                <p:cTn id="9" presetID="10" presetClass="entr" presetSubtype="0" fill="hold" grpId="0" nodeType="clickEffect">
+                                <p:cTn id="8" presetID="10" presetClass="entr" presetSubtype="0" fill="hold" grpId="0" nodeType="afterEffect">
                                   <p:stCondLst>
                                     <p:cond delay="0"/>
                                   </p:stCondLst>
@@ -2443,7 +2435,7 @@
                                   <p:childTnLst>
                                     <p:set>
                                       <p:cBhvr>
-                                        <p:cTn id="10" dur="1" fill="hold">
+                                        <p:cTn id="9" dur="1" fill="hold">
                                           <p:stCondLst>
                                             <p:cond delay="0"/>
                                           </p:stCondLst>
@@ -2461,7 +2453,7 @@
                                     </p:set>
                                     <p:animEffect transition="in" filter="fade">
                                       <p:cBhvr>
-                                        <p:cTn id="11" dur="1500"/>
+                                        <p:cTn id="10" dur="1500"/>
                                         <p:tgtEl>
                                           <p:spTgt spid="8"/>
                                         </p:tgtEl>
@@ -2473,30 +2465,21 @@
                             </p:childTnLst>
                           </p:cTn>
                         </p:par>
-                      </p:childTnLst>
-                    </p:cTn>
-                  </p:par>
-                  <p:par>
-                    <p:cTn id="12" fill="hold">
-                      <p:stCondLst>
-                        <p:cond delay="indefinite"/>
-                      </p:stCondLst>
-                      <p:childTnLst>
                         <p:par>
-                          <p:cTn id="13" fill="hold">
+                          <p:cTn id="11" fill="hold">
                             <p:stCondLst>
-                              <p:cond delay="0"/>
+                              <p:cond delay="1950"/>
                             </p:stCondLst>
                             <p:childTnLst>
                               <p:par>
-                                <p:cTn id="14" presetID="1" presetClass="entr" presetSubtype="0" fill="hold" grpId="0" nodeType="clickEffect">
+                                <p:cTn id="12" presetID="1" presetClass="entr" presetSubtype="0" fill="hold" grpId="0" nodeType="afterEffect">
                                   <p:stCondLst>
                                     <p:cond delay="0"/>
                                   </p:stCondLst>
                                   <p:childTnLst>
                                     <p:set>
                                       <p:cBhvr>
-                                        <p:cTn id="15" dur="1" fill="hold">
+                                        <p:cTn id="13" dur="1" fill="hold">
                                           <p:stCondLst>
                                             <p:cond delay="0"/>
                                           </p:stCondLst>
@@ -2522,26 +2505,26 @@
                     </p:cTn>
                   </p:par>
                   <p:par>
-                    <p:cTn id="16" fill="hold">
+                    <p:cTn id="14" fill="hold">
                       <p:stCondLst>
                         <p:cond delay="indefinite"/>
                       </p:stCondLst>
                       <p:childTnLst>
                         <p:par>
-                          <p:cTn id="17" fill="hold">
+                          <p:cTn id="15" fill="hold">
                             <p:stCondLst>
                               <p:cond delay="0"/>
                             </p:stCondLst>
                             <p:childTnLst>
                               <p:par>
-                                <p:cTn id="18" presetID="1" presetClass="entr" presetSubtype="0" fill="hold" grpId="0" nodeType="clickEffect">
+                                <p:cTn id="16" presetID="1" presetClass="entr" presetSubtype="0" fill="hold" grpId="0" nodeType="clickEffect">
                                   <p:stCondLst>
                                     <p:cond delay="0"/>
                                   </p:stCondLst>
                                   <p:childTnLst>
                                     <p:set>
                                       <p:cBhvr>
-                                        <p:cTn id="19" dur="1" fill="hold">
+                                        <p:cTn id="17" dur="1" fill="hold">
                                           <p:stCondLst>
                                             <p:cond delay="0"/>
                                           </p:stCondLst>
@@ -2563,14 +2546,14 @@
                                 </p:cTn>
                               </p:par>
                               <p:par>
-                                <p:cTn id="20" presetID="1" presetClass="entr" presetSubtype="0" fill="hold" grpId="0" nodeType="withEffect">
+                                <p:cTn id="18" presetID="1" presetClass="entr" presetSubtype="0" fill="hold" grpId="0" nodeType="withEffect">
                                   <p:stCondLst>
                                     <p:cond delay="0"/>
                                   </p:stCondLst>
                                   <p:childTnLst>
                                     <p:set>
                                       <p:cBhvr>
-                                        <p:cTn id="21" dur="1" fill="hold">
+                                        <p:cTn id="19" dur="1" fill="hold">
                                           <p:stCondLst>
                                             <p:cond delay="0"/>
                                           </p:stCondLst>
@@ -2596,30 +2579,21 @@
                             </p:childTnLst>
                           </p:cTn>
                         </p:par>
-                      </p:childTnLst>
-                    </p:cTn>
-                  </p:par>
-                  <p:par>
-                    <p:cTn id="22" fill="hold">
-                      <p:stCondLst>
-                        <p:cond delay="indefinite"/>
-                      </p:stCondLst>
-                      <p:childTnLst>
                         <p:par>
-                          <p:cTn id="23" fill="hold">
+                          <p:cTn id="20" fill="hold">
                             <p:stCondLst>
                               <p:cond delay="0"/>
                             </p:stCondLst>
                             <p:childTnLst>
                               <p:par>
-                                <p:cTn id="24" presetID="1" presetClass="entr" presetSubtype="0" fill="hold" grpId="0" nodeType="clickEffect">
+                                <p:cTn id="21" presetID="1" presetClass="entr" presetSubtype="0" fill="hold" grpId="0" nodeType="afterEffect">
                                   <p:stCondLst>
-                                    <p:cond delay="0"/>
+                                    <p:cond delay="1000"/>
                                   </p:stCondLst>
                                   <p:childTnLst>
                                     <p:set>
                                       <p:cBhvr>
-                                        <p:cTn id="25" dur="1" fill="hold">
+                                        <p:cTn id="22" dur="1" fill="hold">
                                           <p:stCondLst>
                                             <p:cond delay="0"/>
                                           </p:stCondLst>
@@ -2645,30 +2619,21 @@
                             </p:childTnLst>
                           </p:cTn>
                         </p:par>
-                      </p:childTnLst>
-                    </p:cTn>
-                  </p:par>
-                  <p:par>
-                    <p:cTn id="26" fill="hold">
-                      <p:stCondLst>
-                        <p:cond delay="indefinite"/>
-                      </p:stCondLst>
-                      <p:childTnLst>
                         <p:par>
-                          <p:cTn id="27" fill="hold">
+                          <p:cTn id="23" fill="hold">
                             <p:stCondLst>
-                              <p:cond delay="0"/>
+                              <p:cond delay="1000"/>
                             </p:stCondLst>
                             <p:childTnLst>
                               <p:par>
-                                <p:cTn id="28" presetID="1" presetClass="entr" presetSubtype="0" fill="hold" grpId="0" nodeType="clickEffect">
+                                <p:cTn id="24" presetID="1" presetClass="entr" presetSubtype="0" fill="hold" grpId="0" nodeType="afterEffect">
                                   <p:stCondLst>
-                                    <p:cond delay="0"/>
+                                    <p:cond delay="1000"/>
                                   </p:stCondLst>
                                   <p:childTnLst>
                                     <p:set>
                                       <p:cBhvr>
-                                        <p:cTn id="29" dur="1" fill="hold">
+                                        <p:cTn id="25" dur="1" fill="hold">
                                           <p:stCondLst>
                                             <p:cond delay="0"/>
                                           </p:stCondLst>
@@ -2694,30 +2659,21 @@
                             </p:childTnLst>
                           </p:cTn>
                         </p:par>
-                      </p:childTnLst>
-                    </p:cTn>
-                  </p:par>
-                  <p:par>
-                    <p:cTn id="30" fill="hold">
-                      <p:stCondLst>
-                        <p:cond delay="indefinite"/>
-                      </p:stCondLst>
-                      <p:childTnLst>
                         <p:par>
-                          <p:cTn id="31" fill="hold">
+                          <p:cTn id="26" fill="hold">
                             <p:stCondLst>
-                              <p:cond delay="0"/>
+                              <p:cond delay="2000"/>
                             </p:stCondLst>
                             <p:childTnLst>
                               <p:par>
-                                <p:cTn id="32" presetID="1" presetClass="entr" presetSubtype="0" fill="hold" grpId="0" nodeType="clickEffect">
+                                <p:cTn id="27" presetID="1" presetClass="entr" presetSubtype="0" fill="hold" grpId="0" nodeType="afterEffect">
                                   <p:stCondLst>
-                                    <p:cond delay="0"/>
+                                    <p:cond delay="1000"/>
                                   </p:stCondLst>
                                   <p:childTnLst>
                                     <p:set>
                                       <p:cBhvr>
-                                        <p:cTn id="33" dur="1" fill="hold">
+                                        <p:cTn id="28" dur="1" fill="hold">
                                           <p:stCondLst>
                                             <p:cond delay="0"/>
                                           </p:stCondLst>
@@ -2743,30 +2699,21 @@
                             </p:childTnLst>
                           </p:cTn>
                         </p:par>
-                      </p:childTnLst>
-                    </p:cTn>
-                  </p:par>
-                  <p:par>
-                    <p:cTn id="34" fill="hold">
-                      <p:stCondLst>
-                        <p:cond delay="indefinite"/>
-                      </p:stCondLst>
-                      <p:childTnLst>
                         <p:par>
-                          <p:cTn id="35" fill="hold">
+                          <p:cTn id="29" fill="hold">
                             <p:stCondLst>
-                              <p:cond delay="0"/>
+                              <p:cond delay="3000"/>
                             </p:stCondLst>
                             <p:childTnLst>
                               <p:par>
-                                <p:cTn id="36" presetID="1" presetClass="entr" presetSubtype="0" fill="hold" grpId="0" nodeType="clickEffect">
+                                <p:cTn id="30" presetID="1" presetClass="entr" presetSubtype="0" fill="hold" grpId="0" nodeType="afterEffect">
                                   <p:stCondLst>
-                                    <p:cond delay="0"/>
+                                    <p:cond delay="250"/>
                                   </p:stCondLst>
                                   <p:childTnLst>
                                     <p:set>
                                       <p:cBhvr>
-                                        <p:cTn id="37" dur="1" fill="hold">
+                                        <p:cTn id="31" dur="1" fill="hold">
                                           <p:stCondLst>
                                             <p:cond delay="0"/>
                                           </p:stCondLst>
@@ -4661,6 +4608,936 @@
 
 <file path=ppt/slides/slide3.xml><?xml version="1.0" encoding="utf-8"?>
 <p:sld xmlns:a="http://schemas.openxmlformats.org/drawingml/2006/main" xmlns:r="http://schemas.openxmlformats.org/officeDocument/2006/relationships" xmlns:p="http://schemas.openxmlformats.org/presentationml/2006/main">
+  <p:cSld name="Slide 3 Inconvenients">
+    <p:bg>
+      <p:bgPr>
+        <a:solidFill>
+          <a:srgbClr val="0B1733"/>
+        </a:solidFill>
+        <a:effectLst/>
+      </p:bgPr>
+    </p:bg>
+    <p:spTree>
+      <p:nvGrpSpPr>
+        <p:cNvPr id="1" name=""/>
+        <p:cNvGrpSpPr/>
+        <p:nvPr/>
+      </p:nvGrpSpPr>
+      <p:grpSpPr>
+        <a:xfrm>
+          <a:off x="0" y="0"/>
+          <a:ext cx="0" cy="0"/>
+          <a:chOff x="0" y="0"/>
+          <a:chExt cx="0" cy="0"/>
+        </a:xfrm>
+      </p:grpSpPr>
+      <p:sp>
+        <p:nvSpPr>
+          <p:cNvPr id="2" name="Eyebrow"/>
+          <p:cNvSpPr/>
+          <p:nvPr/>
+        </p:nvSpPr>
+        <p:spPr>
+          <a:xfrm>
+            <a:off x="640080" y="457200"/>
+            <a:ext cx="10912080" cy="320040"/>
+          </a:xfrm>
+          <a:prstGeom prst="rect">
+            <a:avLst/>
+          </a:prstGeom>
+          <a:noFill/>
+          <a:ln/>
+        </p:spPr>
+        <p:txBody>
+          <a:bodyPr wrap="square" lIns="0" tIns="0" rIns="0" bIns="0" rtlCol="0" anchor="ctr"/>
+          <a:lstStyle/>
+          <a:p>
+            <a:pPr marL="0" indent="0">
+              <a:buNone/>
+            </a:pPr>
+            <a:r>
+              <a:rPr lang="fr-FR" sz="1250" b="1" kern="0" spc="300" noProof="0">
+                <a:solidFill>
+                  <a:srgbClr val="E8B23A"/>
+                </a:solidFill>
+                <a:latin typeface="Calibri" pitchFamily="34" charset="0"/>
+                <a:ea typeface="Calibri" pitchFamily="34" charset="-122"/>
+                <a:cs typeface="Calibri" pitchFamily="34" charset="-120"/>
+              </a:rPr>
+              <a:t>LES INCONVÉNIENTS</a:t>
+            </a:r>
+            <a:endParaRPr lang="fr-FR" sz="1250" noProof="0"/>
+          </a:p>
+        </p:txBody>
+      </p:sp>
+      <p:sp>
+        <p:nvSpPr>
+          <p:cNvPr id="3" name="Title"/>
+          <p:cNvSpPr/>
+          <p:nvPr/>
+        </p:nvSpPr>
+        <p:spPr>
+          <a:xfrm>
+            <a:off x="640080" y="828536"/>
+            <a:ext cx="10912080" cy="868680"/>
+          </a:xfrm>
+          <a:prstGeom prst="rect">
+            <a:avLst/>
+          </a:prstGeom>
+          <a:noFill/>
+          <a:ln/>
+        </p:spPr>
+        <p:txBody>
+          <a:bodyPr wrap="square" lIns="0" tIns="0" rIns="0" bIns="0" rtlCol="0" anchor="ctr"/>
+          <a:lstStyle/>
+          <a:p>
+            <a:pPr marL="0" indent="0">
+              <a:lnSpc>
+                <a:spcPts val="3400"/>
+              </a:lnSpc>
+              <a:buNone/>
+            </a:pPr>
+            <a:r>
+              <a:rPr lang="fr-FR" sz="3100" b="1" noProof="0">
+                <a:solidFill>
+                  <a:srgbClr val="FFFFFF"/>
+                </a:solidFill>
+                <a:latin typeface="Georgia" pitchFamily="34" charset="0"/>
+                <a:ea typeface="Georgia" pitchFamily="34" charset="-122"/>
+                <a:cs typeface="Georgia" pitchFamily="34" charset="-120"/>
+              </a:rPr>
+              <a:t>Le CV oblige à traduire, deviner et déformer</a:t>
+            </a:r>
+            <a:endParaRPr lang="fr-FR" sz="3100" noProof="0"/>
+          </a:p>
+        </p:txBody>
+      </p:sp>
+      <p:grpSp>
+        <p:nvGrpSpPr>
+          <p:cNvPr id="20" name="Card 1"/>
+          <p:cNvGrpSpPr/>
+          <p:nvPr/>
+        </p:nvGrpSpPr>
+        <p:grpSpPr>
+          <a:xfrm>
+            <a:off x="640080" y="1980000"/>
+            <a:ext cx="3450000" cy="3900000"/>
+            <a:chOff x="640080" y="1980000"/>
+            <a:chExt cx="3450000" cy="3900000"/>
+          </a:xfrm>
+        </p:grpSpPr>
+        <p:sp>
+          <p:nvSpPr>
+            <p:cNvPr id="21" name="Card 1 bg"/>
+            <p:cNvSpPr/>
+            <p:nvPr/>
+          </p:nvSpPr>
+          <p:spPr>
+            <a:xfrm>
+              <a:off x="640080" y="1980000"/>
+              <a:ext cx="3450000" cy="3900000"/>
+            </a:xfrm>
+            <a:prstGeom prst="rect">
+              <a:avLst/>
+            </a:prstGeom>
+            <a:solidFill>
+              <a:srgbClr val="1B2D52"/>
+            </a:solidFill>
+            <a:ln/>
+            <a:effectLst>
+              <a:outerShdw blurRad="114300" dist="38100" dir="5400000" algn="bl" rotWithShape="0">
+                <a:srgbClr val="000000">
+                  <a:alpha val="28000"/>
+                </a:srgbClr>
+              </a:outerShdw>
+            </a:effectLst>
+          </p:spPr>
+          <p:txBody>
+            <a:bodyPr/>
+            <a:lstStyle/>
+            <a:p>
+              <a:endParaRPr lang="fr-FR" noProof="0"/>
+            </a:p>
+          </p:txBody>
+        </p:sp>
+        <p:sp>
+          <p:nvSpPr>
+            <p:cNvPr id="22" name="Card 1 bar"/>
+            <p:cNvSpPr/>
+            <p:nvPr/>
+          </p:nvSpPr>
+          <p:spPr>
+            <a:xfrm>
+              <a:off x="640080" y="1980000"/>
+              <a:ext cx="3450000" cy="82296"/>
+            </a:xfrm>
+            <a:prstGeom prst="rect">
+              <a:avLst/>
+            </a:prstGeom>
+            <a:solidFill>
+              <a:srgbClr val="E8B23A"/>
+            </a:solidFill>
+            <a:ln/>
+          </p:spPr>
+          <p:txBody>
+            <a:bodyPr/>
+            <a:lstStyle/>
+            <a:p>
+              <a:endParaRPr lang="fr-FR" noProof="0"/>
+            </a:p>
+          </p:txBody>
+        </p:sp>
+        <p:sp>
+          <p:nvSpPr>
+            <p:cNvPr id="23" name="Card 1 num"/>
+            <p:cNvSpPr/>
+            <p:nvPr/>
+          </p:nvSpPr>
+          <p:spPr>
+            <a:xfrm>
+              <a:off x="900080" y="2280000"/>
+              <a:ext cx="2930000" cy="760000"/>
+            </a:xfrm>
+            <a:prstGeom prst="rect">
+              <a:avLst/>
+            </a:prstGeom>
+            <a:noFill/>
+            <a:ln/>
+          </p:spPr>
+          <p:txBody>
+            <a:bodyPr wrap="square" lIns="0" tIns="0" rIns="0" bIns="0" rtlCol="0" anchor="ctr"/>
+            <a:lstStyle/>
+            <a:p>
+              <a:pPr marL="0" indent="0">
+                <a:buNone/>
+              </a:pPr>
+              <a:r>
+                <a:rPr lang="fr-FR" sz="4000" b="1" noProof="0" dirty="0">
+                  <a:solidFill>
+                    <a:srgbClr val="E8B23A"/>
+                  </a:solidFill>
+                  <a:latin typeface="Georgia" pitchFamily="34" charset="0"/>
+                  <a:ea typeface="Georgia" pitchFamily="34" charset="-122"/>
+                  <a:cs typeface="Georgia" pitchFamily="34" charset="-120"/>
+                </a:rPr>
+                <a:t>01</a:t>
+              </a:r>
+              <a:endParaRPr lang="fr-FR" sz="4000" noProof="0" dirty="0"/>
+            </a:p>
+          </p:txBody>
+        </p:sp>
+        <p:sp>
+          <p:nvSpPr>
+            <p:cNvPr id="24" name="Card 1 title"/>
+            <p:cNvSpPr/>
+            <p:nvPr/>
+          </p:nvSpPr>
+          <p:spPr>
+            <a:xfrm>
+              <a:off x="900080" y="3120000"/>
+              <a:ext cx="2930000" cy="560000"/>
+            </a:xfrm>
+            <a:prstGeom prst="rect">
+              <a:avLst/>
+            </a:prstGeom>
+            <a:noFill/>
+            <a:ln/>
+          </p:spPr>
+          <p:txBody>
+            <a:bodyPr wrap="square" lIns="0" tIns="0" rIns="0" bIns="0" rtlCol="0" anchor="ctr"/>
+            <a:lstStyle/>
+            <a:p>
+              <a:pPr marL="0" indent="0">
+                <a:buNone/>
+              </a:pPr>
+              <a:r>
+                <a:rPr lang="fr-FR" sz="1700" b="1" noProof="0">
+                  <a:solidFill>
+                    <a:srgbClr val="FFFFFF"/>
+                  </a:solidFill>
+                  <a:latin typeface="Georgia" pitchFamily="34" charset="0"/>
+                  <a:ea typeface="Georgia" pitchFamily="34" charset="-122"/>
+                  <a:cs typeface="Georgia" pitchFamily="34" charset="-120"/>
+                </a:rPr>
+                <a:t>Le candidat devine</a:t>
+              </a:r>
+              <a:endParaRPr lang="fr-FR" sz="1700" noProof="0"/>
+            </a:p>
+          </p:txBody>
+        </p:sp>
+        <p:sp>
+          <p:nvSpPr>
+            <p:cNvPr id="25" name="Card 1 desc"/>
+            <p:cNvSpPr/>
+            <p:nvPr/>
+          </p:nvSpPr>
+          <p:spPr>
+            <a:xfrm>
+              <a:off x="900080" y="3760000"/>
+              <a:ext cx="2930000" cy="1900000"/>
+            </a:xfrm>
+            <a:prstGeom prst="rect">
+              <a:avLst/>
+            </a:prstGeom>
+            <a:noFill/>
+            <a:ln/>
+          </p:spPr>
+          <p:txBody>
+            <a:bodyPr wrap="square" lIns="0" tIns="0" rIns="0" bIns="0" rtlCol="0" anchor="t"/>
+            <a:lstStyle/>
+            <a:p>
+              <a:pPr marL="0" indent="0">
+                <a:lnSpc>
+                  <a:spcPts val="2000"/>
+                </a:lnSpc>
+                <a:buNone/>
+              </a:pPr>
+              <a:r>
+                <a:rPr lang="fr-FR" sz="1400" noProof="0">
+                  <a:solidFill>
+                    <a:srgbClr val="C7D2E6"/>
+                  </a:solidFill>
+                  <a:latin typeface="Calibri" pitchFamily="34" charset="0"/>
+                  <a:ea typeface="Calibri" pitchFamily="34" charset="-122"/>
+                  <a:cs typeface="Calibri" pitchFamily="34" charset="-120"/>
+                </a:rPr>
+                <a:t>Le candidat doit imaginer quelles données intéresseront le recruteur.</a:t>
+              </a:r>
+              <a:endParaRPr lang="fr-FR" sz="1400" noProof="0"/>
+            </a:p>
+          </p:txBody>
+        </p:sp>
+      </p:grpSp>
+      <p:grpSp>
+        <p:nvGrpSpPr>
+          <p:cNvPr id="30" name="Card 2"/>
+          <p:cNvGrpSpPr/>
+          <p:nvPr/>
+        </p:nvGrpSpPr>
+        <p:grpSpPr>
+          <a:xfrm>
+            <a:off x="4371120" y="1980000"/>
+            <a:ext cx="3450000" cy="3900000"/>
+            <a:chOff x="4371120" y="1980000"/>
+            <a:chExt cx="3450000" cy="3900000"/>
+          </a:xfrm>
+        </p:grpSpPr>
+        <p:sp>
+          <p:nvSpPr>
+            <p:cNvPr id="31" name="Card 2 bg"/>
+            <p:cNvSpPr/>
+            <p:nvPr/>
+          </p:nvSpPr>
+          <p:spPr>
+            <a:xfrm>
+              <a:off x="4371120" y="1980000"/>
+              <a:ext cx="3450000" cy="3900000"/>
+            </a:xfrm>
+            <a:prstGeom prst="rect">
+              <a:avLst/>
+            </a:prstGeom>
+            <a:solidFill>
+              <a:srgbClr val="1B2D52"/>
+            </a:solidFill>
+            <a:ln/>
+            <a:effectLst>
+              <a:outerShdw blurRad="114300" dist="38100" dir="5400000" algn="bl" rotWithShape="0">
+                <a:srgbClr val="000000">
+                  <a:alpha val="28000"/>
+                </a:srgbClr>
+              </a:outerShdw>
+            </a:effectLst>
+          </p:spPr>
+          <p:txBody>
+            <a:bodyPr/>
+            <a:lstStyle/>
+            <a:p>
+              <a:endParaRPr lang="fr-FR" noProof="0"/>
+            </a:p>
+          </p:txBody>
+        </p:sp>
+        <p:sp>
+          <p:nvSpPr>
+            <p:cNvPr id="32" name="Card 2 bar"/>
+            <p:cNvSpPr/>
+            <p:nvPr/>
+          </p:nvSpPr>
+          <p:spPr>
+            <a:xfrm>
+              <a:off x="4371120" y="1980000"/>
+              <a:ext cx="3450000" cy="82296"/>
+            </a:xfrm>
+            <a:prstGeom prst="rect">
+              <a:avLst/>
+            </a:prstGeom>
+            <a:solidFill>
+              <a:srgbClr val="4FD1E0"/>
+            </a:solidFill>
+            <a:ln/>
+          </p:spPr>
+          <p:txBody>
+            <a:bodyPr/>
+            <a:lstStyle/>
+            <a:p>
+              <a:endParaRPr lang="fr-FR" noProof="0"/>
+            </a:p>
+          </p:txBody>
+        </p:sp>
+        <p:sp>
+          <p:nvSpPr>
+            <p:cNvPr id="33" name="Card 2 num"/>
+            <p:cNvSpPr/>
+            <p:nvPr/>
+          </p:nvSpPr>
+          <p:spPr>
+            <a:xfrm>
+              <a:off x="4631120" y="2280000"/>
+              <a:ext cx="2930000" cy="760000"/>
+            </a:xfrm>
+            <a:prstGeom prst="rect">
+              <a:avLst/>
+            </a:prstGeom>
+            <a:noFill/>
+            <a:ln/>
+          </p:spPr>
+          <p:txBody>
+            <a:bodyPr wrap="square" lIns="0" tIns="0" rIns="0" bIns="0" rtlCol="0" anchor="ctr"/>
+            <a:lstStyle/>
+            <a:p>
+              <a:pPr marL="0" indent="0">
+                <a:buNone/>
+              </a:pPr>
+              <a:r>
+                <a:rPr lang="fr-FR" sz="4000" b="1" noProof="0" dirty="0">
+                  <a:solidFill>
+                    <a:srgbClr val="4FD1E0"/>
+                  </a:solidFill>
+                  <a:latin typeface="Georgia" pitchFamily="34" charset="0"/>
+                  <a:ea typeface="Georgia" pitchFamily="34" charset="-122"/>
+                  <a:cs typeface="Georgia" pitchFamily="34" charset="-120"/>
+                </a:rPr>
+                <a:t>02</a:t>
+              </a:r>
+              <a:endParaRPr lang="fr-FR" sz="4000" noProof="0" dirty="0"/>
+            </a:p>
+          </p:txBody>
+        </p:sp>
+        <p:sp>
+          <p:nvSpPr>
+            <p:cNvPr id="34" name="Card 2 title"/>
+            <p:cNvSpPr/>
+            <p:nvPr/>
+          </p:nvSpPr>
+          <p:spPr>
+            <a:xfrm>
+              <a:off x="4631120" y="3120000"/>
+              <a:ext cx="2930000" cy="560000"/>
+            </a:xfrm>
+            <a:prstGeom prst="rect">
+              <a:avLst/>
+            </a:prstGeom>
+            <a:noFill/>
+            <a:ln/>
+          </p:spPr>
+          <p:txBody>
+            <a:bodyPr wrap="square" lIns="0" tIns="0" rIns="0" bIns="0" rtlCol="0" anchor="ctr"/>
+            <a:lstStyle/>
+            <a:p>
+              <a:pPr marL="0" indent="0">
+                <a:buNone/>
+              </a:pPr>
+              <a:r>
+                <a:rPr lang="fr-FR" sz="1700" b="1" noProof="0">
+                  <a:solidFill>
+                    <a:srgbClr val="FFFFFF"/>
+                  </a:solidFill>
+                  <a:latin typeface="Georgia" pitchFamily="34" charset="0"/>
+                  <a:ea typeface="Georgia" pitchFamily="34" charset="-122"/>
+                  <a:cs typeface="Georgia" pitchFamily="34" charset="-120"/>
+                </a:rPr>
+                <a:t>La machine interprète</a:t>
+              </a:r>
+              <a:endParaRPr lang="fr-FR" sz="1700" noProof="0"/>
+            </a:p>
+          </p:txBody>
+        </p:sp>
+        <p:sp>
+          <p:nvSpPr>
+            <p:cNvPr id="35" name="Card 2 desc"/>
+            <p:cNvSpPr/>
+            <p:nvPr/>
+          </p:nvSpPr>
+          <p:spPr>
+            <a:xfrm>
+              <a:off x="4631120" y="3760000"/>
+              <a:ext cx="2930000" cy="1900000"/>
+            </a:xfrm>
+            <a:prstGeom prst="rect">
+              <a:avLst/>
+            </a:prstGeom>
+            <a:noFill/>
+            <a:ln/>
+          </p:spPr>
+          <p:txBody>
+            <a:bodyPr wrap="square" lIns="0" tIns="0" rIns="0" bIns="0" rtlCol="0" anchor="t"/>
+            <a:lstStyle/>
+            <a:p>
+              <a:pPr marL="0" indent="0">
+                <a:lnSpc>
+                  <a:spcPts val="2000"/>
+                </a:lnSpc>
+                <a:buNone/>
+              </a:pPr>
+              <a:r>
+                <a:rPr lang="fr-FR" sz="1400" noProof="0">
+                  <a:solidFill>
+                    <a:srgbClr val="C7D2E6"/>
+                  </a:solidFill>
+                  <a:latin typeface="Calibri" pitchFamily="34" charset="0"/>
+                  <a:ea typeface="Calibri" pitchFamily="34" charset="-122"/>
+                  <a:cs typeface="Calibri" pitchFamily="34" charset="-120"/>
+                </a:rPr>
+                <a:t>La machine doit comprendre la personnalité et les compétences, et imaginer celles qui sont absentes.</a:t>
+              </a:r>
+              <a:endParaRPr lang="fr-FR" sz="1400" noProof="0"/>
+            </a:p>
+          </p:txBody>
+        </p:sp>
+      </p:grpSp>
+      <p:grpSp>
+        <p:nvGrpSpPr>
+          <p:cNvPr id="40" name="Card 3"/>
+          <p:cNvGrpSpPr/>
+          <p:nvPr/>
+        </p:nvGrpSpPr>
+        <p:grpSpPr>
+          <a:xfrm>
+            <a:off x="8102160" y="1980000"/>
+            <a:ext cx="3450000" cy="3900000"/>
+            <a:chOff x="8102160" y="1980000"/>
+            <a:chExt cx="3450000" cy="3900000"/>
+          </a:xfrm>
+        </p:grpSpPr>
+        <p:sp>
+          <p:nvSpPr>
+            <p:cNvPr id="41" name="Card 3 bg"/>
+            <p:cNvSpPr/>
+            <p:nvPr/>
+          </p:nvSpPr>
+          <p:spPr>
+            <a:xfrm>
+              <a:off x="8102160" y="1980000"/>
+              <a:ext cx="3450000" cy="3900000"/>
+            </a:xfrm>
+            <a:prstGeom prst="rect">
+              <a:avLst/>
+            </a:prstGeom>
+            <a:solidFill>
+              <a:srgbClr val="1B2D52"/>
+            </a:solidFill>
+            <a:ln/>
+            <a:effectLst>
+              <a:outerShdw blurRad="114300" dist="38100" dir="5400000" algn="bl" rotWithShape="0">
+                <a:srgbClr val="000000">
+                  <a:alpha val="28000"/>
+                </a:srgbClr>
+              </a:outerShdw>
+            </a:effectLst>
+          </p:spPr>
+          <p:txBody>
+            <a:bodyPr/>
+            <a:lstStyle/>
+            <a:p>
+              <a:endParaRPr lang="fr-FR" noProof="0"/>
+            </a:p>
+          </p:txBody>
+        </p:sp>
+        <p:sp>
+          <p:nvSpPr>
+            <p:cNvPr id="42" name="Card 3 bar"/>
+            <p:cNvSpPr/>
+            <p:nvPr/>
+          </p:nvSpPr>
+          <p:spPr>
+            <a:xfrm>
+              <a:off x="8102160" y="1980000"/>
+              <a:ext cx="3450000" cy="82296"/>
+            </a:xfrm>
+            <a:prstGeom prst="rect">
+              <a:avLst/>
+            </a:prstGeom>
+            <a:solidFill>
+              <a:srgbClr val="E8B23A"/>
+            </a:solidFill>
+            <a:ln/>
+          </p:spPr>
+          <p:txBody>
+            <a:bodyPr/>
+            <a:lstStyle/>
+            <a:p>
+              <a:endParaRPr lang="fr-FR" noProof="0"/>
+            </a:p>
+          </p:txBody>
+        </p:sp>
+        <p:sp>
+          <p:nvSpPr>
+            <p:cNvPr id="43" name="Card 3 num"/>
+            <p:cNvSpPr/>
+            <p:nvPr/>
+          </p:nvSpPr>
+          <p:spPr>
+            <a:xfrm>
+              <a:off x="8362160" y="2280000"/>
+              <a:ext cx="2930000" cy="760000"/>
+            </a:xfrm>
+            <a:prstGeom prst="rect">
+              <a:avLst/>
+            </a:prstGeom>
+            <a:noFill/>
+            <a:ln/>
+          </p:spPr>
+          <p:txBody>
+            <a:bodyPr wrap="square" lIns="0" tIns="0" rIns="0" bIns="0" rtlCol="0" anchor="ctr"/>
+            <a:lstStyle/>
+            <a:p>
+              <a:pPr marL="0" indent="0">
+                <a:buNone/>
+              </a:pPr>
+              <a:r>
+                <a:rPr lang="fr-FR" sz="4000" b="1" noProof="0">
+                  <a:solidFill>
+                    <a:srgbClr val="E8B23A"/>
+                  </a:solidFill>
+                  <a:latin typeface="Georgia" pitchFamily="34" charset="0"/>
+                  <a:ea typeface="Georgia" pitchFamily="34" charset="-122"/>
+                  <a:cs typeface="Georgia" pitchFamily="34" charset="-120"/>
+                </a:rPr>
+                <a:t>03</a:t>
+              </a:r>
+              <a:endParaRPr lang="fr-FR" sz="4000" noProof="0"/>
+            </a:p>
+          </p:txBody>
+        </p:sp>
+        <p:sp>
+          <p:nvSpPr>
+            <p:cNvPr id="44" name="Card 3 title"/>
+            <p:cNvSpPr/>
+            <p:nvPr/>
+          </p:nvSpPr>
+          <p:spPr>
+            <a:xfrm>
+              <a:off x="8362160" y="3120000"/>
+              <a:ext cx="2930000" cy="560000"/>
+            </a:xfrm>
+            <a:prstGeom prst="rect">
+              <a:avLst/>
+            </a:prstGeom>
+            <a:noFill/>
+            <a:ln/>
+          </p:spPr>
+          <p:txBody>
+            <a:bodyPr wrap="square" lIns="0" tIns="0" rIns="0" bIns="0" rtlCol="0" anchor="ctr"/>
+            <a:lstStyle/>
+            <a:p>
+              <a:pPr marL="0" indent="0">
+                <a:buNone/>
+              </a:pPr>
+              <a:r>
+                <a:rPr lang="fr-FR" sz="1700" b="1" noProof="0">
+                  <a:solidFill>
+                    <a:srgbClr val="FFFFFF"/>
+                  </a:solidFill>
+                  <a:latin typeface="Georgia" pitchFamily="34" charset="0"/>
+                  <a:ea typeface="Georgia" pitchFamily="34" charset="-122"/>
+                  <a:cs typeface="Georgia" pitchFamily="34" charset="-120"/>
+                </a:rPr>
+                <a:t>La forme l'emporte</a:t>
+              </a:r>
+              <a:endParaRPr lang="fr-FR" sz="1700" noProof="0"/>
+            </a:p>
+          </p:txBody>
+        </p:sp>
+        <p:sp>
+          <p:nvSpPr>
+            <p:cNvPr id="45" name="Card 3 desc"/>
+            <p:cNvSpPr/>
+            <p:nvPr/>
+          </p:nvSpPr>
+          <p:spPr>
+            <a:xfrm>
+              <a:off x="8362160" y="3760000"/>
+              <a:ext cx="2930000" cy="1900000"/>
+            </a:xfrm>
+            <a:prstGeom prst="rect">
+              <a:avLst/>
+            </a:prstGeom>
+            <a:noFill/>
+            <a:ln/>
+          </p:spPr>
+          <p:txBody>
+            <a:bodyPr wrap="square" lIns="0" tIns="0" rIns="0" bIns="0" rtlCol="0" anchor="t"/>
+            <a:lstStyle/>
+            <a:p>
+              <a:pPr marL="0" indent="0">
+                <a:lnSpc>
+                  <a:spcPts val="2000"/>
+                </a:lnSpc>
+                <a:buNone/>
+              </a:pPr>
+              <a:r>
+                <a:rPr lang="fr-FR" sz="1400" noProof="0">
+                  <a:solidFill>
+                    <a:srgbClr val="C7D2E6"/>
+                  </a:solidFill>
+                  <a:latin typeface="Calibri" pitchFamily="34" charset="0"/>
+                  <a:ea typeface="Calibri" pitchFamily="34" charset="-122"/>
+                  <a:cs typeface="Calibri" pitchFamily="34" charset="-120"/>
+                </a:rPr>
+                <a:t>La donnée disparaît derrière la forme, créant ainsi des biais.</a:t>
+              </a:r>
+              <a:endParaRPr lang="fr-FR" sz="1400" noProof="0"/>
+            </a:p>
+          </p:txBody>
+        </p:sp>
+      </p:grpSp>
+      <p:sp>
+        <p:nvSpPr>
+          <p:cNvPr id="50" name="Page number"/>
+          <p:cNvSpPr/>
+          <p:nvPr/>
+        </p:nvSpPr>
+        <p:spPr>
+          <a:xfrm>
+            <a:off x="11430000" y="6355080"/>
+            <a:ext cx="640080" cy="365760"/>
+          </a:xfrm>
+          <a:prstGeom prst="rect">
+            <a:avLst/>
+          </a:prstGeom>
+          <a:noFill/>
+          <a:ln/>
+        </p:spPr>
+        <p:txBody>
+          <a:bodyPr wrap="square" lIns="0" tIns="0" rIns="0" bIns="0" rtlCol="0" anchor="ctr"/>
+          <a:lstStyle/>
+          <a:p>
+            <a:pPr marL="0" indent="0" algn="r">
+              <a:buNone/>
+            </a:pPr>
+            <a:r>
+              <a:rPr lang="fr-FR" sz="1100" noProof="0">
+                <a:solidFill>
+                  <a:srgbClr val="9FB0CD"/>
+                </a:solidFill>
+                <a:latin typeface="Calibri" pitchFamily="34" charset="0"/>
+                <a:ea typeface="Calibri" pitchFamily="34" charset="-122"/>
+                <a:cs typeface="Calibri" pitchFamily="34" charset="-120"/>
+              </a:rPr>
+              <a:t>03</a:t>
+            </a:r>
+            <a:endParaRPr lang="fr-FR" sz="1100" noProof="0"/>
+          </a:p>
+        </p:txBody>
+      </p:sp>
+    </p:spTree>
+  </p:cSld>
+  <p:clrMapOvr>
+    <a:masterClrMapping/>
+  </p:clrMapOvr>
+  <p:timing>
+    <p:tnLst>
+      <p:par>
+        <p:cTn id="1" dur="indefinite" restart="never" nodeType="tmRoot">
+          <p:childTnLst>
+            <p:seq concurrent="1" nextAc="seek">
+              <p:cTn id="2" dur="indefinite" nodeType="mainSeq">
+                <p:childTnLst>
+                  <p:par>
+                    <p:cTn id="3" fill="hold">
+                      <p:stCondLst>
+                        <p:cond delay="indefinite"/>
+                      </p:stCondLst>
+                      <p:childTnLst>
+                        <p:par>
+                          <p:cTn id="4" fill="hold">
+                            <p:stCondLst>
+                              <p:cond delay="0"/>
+                            </p:stCondLst>
+                            <p:childTnLst>
+                              <p:par>
+                                <p:cTn id="5" presetID="10" presetClass="entr" presetSubtype="0" fill="hold" nodeType="clickEffect">
+                                  <p:stCondLst>
+                                    <p:cond delay="0"/>
+                                  </p:stCondLst>
+                                  <p:childTnLst>
+                                    <p:set>
+                                      <p:cBhvr>
+                                        <p:cTn id="6" dur="1" fill="hold">
+                                          <p:stCondLst>
+                                            <p:cond delay="0"/>
+                                          </p:stCondLst>
+                                        </p:cTn>
+                                        <p:tgtEl>
+                                          <p:spTgt spid="20"/>
+                                        </p:tgtEl>
+                                        <p:attrNameLst>
+                                          <p:attrName>style.visibility</p:attrName>
+                                        </p:attrNameLst>
+                                      </p:cBhvr>
+                                      <p:to>
+                                        <p:strVal val="visible"/>
+                                      </p:to>
+                                    </p:set>
+                                    <p:animEffect transition="in" filter="fade">
+                                      <p:cBhvr>
+                                        <p:cTn id="7" dur="500"/>
+                                        <p:tgtEl>
+                                          <p:spTgt spid="20"/>
+                                        </p:tgtEl>
+                                      </p:cBhvr>
+                                    </p:animEffect>
+                                  </p:childTnLst>
+                                </p:cTn>
+                              </p:par>
+                            </p:childTnLst>
+                          </p:cTn>
+                        </p:par>
+                      </p:childTnLst>
+                    </p:cTn>
+                  </p:par>
+                  <p:par>
+                    <p:cTn id="8" fill="hold">
+                      <p:stCondLst>
+                        <p:cond delay="indefinite"/>
+                      </p:stCondLst>
+                      <p:childTnLst>
+                        <p:par>
+                          <p:cTn id="9" fill="hold">
+                            <p:stCondLst>
+                              <p:cond delay="0"/>
+                            </p:stCondLst>
+                            <p:childTnLst>
+                              <p:par>
+                                <p:cTn id="10" presetID="10" presetClass="entr" presetSubtype="0" fill="hold" nodeType="clickEffect">
+                                  <p:stCondLst>
+                                    <p:cond delay="0"/>
+                                  </p:stCondLst>
+                                  <p:childTnLst>
+                                    <p:set>
+                                      <p:cBhvr>
+                                        <p:cTn id="11" dur="1" fill="hold">
+                                          <p:stCondLst>
+                                            <p:cond delay="0"/>
+                                          </p:stCondLst>
+                                        </p:cTn>
+                                        <p:tgtEl>
+                                          <p:spTgt spid="30"/>
+                                        </p:tgtEl>
+                                        <p:attrNameLst>
+                                          <p:attrName>style.visibility</p:attrName>
+                                        </p:attrNameLst>
+                                      </p:cBhvr>
+                                      <p:to>
+                                        <p:strVal val="visible"/>
+                                      </p:to>
+                                    </p:set>
+                                    <p:animEffect transition="in" filter="fade">
+                                      <p:cBhvr>
+                                        <p:cTn id="12" dur="500"/>
+                                        <p:tgtEl>
+                                          <p:spTgt spid="30"/>
+                                        </p:tgtEl>
+                                      </p:cBhvr>
+                                    </p:animEffect>
+                                  </p:childTnLst>
+                                </p:cTn>
+                              </p:par>
+                            </p:childTnLst>
+                          </p:cTn>
+                        </p:par>
+                      </p:childTnLst>
+                    </p:cTn>
+                  </p:par>
+                  <p:par>
+                    <p:cTn id="13" fill="hold">
+                      <p:stCondLst>
+                        <p:cond delay="indefinite"/>
+                      </p:stCondLst>
+                      <p:childTnLst>
+                        <p:par>
+                          <p:cTn id="14" fill="hold">
+                            <p:stCondLst>
+                              <p:cond delay="0"/>
+                            </p:stCondLst>
+                            <p:childTnLst>
+                              <p:par>
+                                <p:cTn id="15" presetID="10" presetClass="entr" presetSubtype="0" fill="hold" nodeType="clickEffect">
+                                  <p:stCondLst>
+                                    <p:cond delay="0"/>
+                                  </p:stCondLst>
+                                  <p:childTnLst>
+                                    <p:set>
+                                      <p:cBhvr>
+                                        <p:cTn id="16" dur="1" fill="hold">
+                                          <p:stCondLst>
+                                            <p:cond delay="0"/>
+                                          </p:stCondLst>
+                                        </p:cTn>
+                                        <p:tgtEl>
+                                          <p:spTgt spid="40"/>
+                                        </p:tgtEl>
+                                        <p:attrNameLst>
+                                          <p:attrName>style.visibility</p:attrName>
+                                        </p:attrNameLst>
+                                      </p:cBhvr>
+                                      <p:to>
+                                        <p:strVal val="visible"/>
+                                      </p:to>
+                                    </p:set>
+                                    <p:animEffect transition="in" filter="fade">
+                                      <p:cBhvr>
+                                        <p:cTn id="17" dur="500"/>
+                                        <p:tgtEl>
+                                          <p:spTgt spid="40"/>
+                                        </p:tgtEl>
+                                      </p:cBhvr>
+                                    </p:animEffect>
+                                  </p:childTnLst>
+                                </p:cTn>
+                              </p:par>
+                            </p:childTnLst>
+                          </p:cTn>
+                        </p:par>
+                      </p:childTnLst>
+                    </p:cTn>
+                  </p:par>
+                </p:childTnLst>
+              </p:cTn>
+              <p:prevCondLst>
+                <p:cond evt="onPrev" delay="0">
+                  <p:tgtEl>
+                    <p:sldTgt/>
+                  </p:tgtEl>
+                </p:cond>
+              </p:prevCondLst>
+              <p:nextCondLst>
+                <p:cond evt="onNext" delay="0">
+                  <p:tgtEl>
+                    <p:sldTgt/>
+                  </p:tgtEl>
+                </p:cond>
+              </p:nextCondLst>
+            </p:seq>
+          </p:childTnLst>
+        </p:cTn>
+      </p:par>
+    </p:tnLst>
+  </p:timing>
+</p:sld>
+</file>
+
+<file path=ppt/slides/slide4.xml><?xml version="1.0" encoding="utf-8"?>
+<p:sld xmlns:a="http://schemas.openxmlformats.org/drawingml/2006/main" xmlns:r="http://schemas.openxmlformats.org/officeDocument/2006/relationships" xmlns:p="http://schemas.openxmlformats.org/presentationml/2006/main">
   <p:cSld name="Slide 3">
     <p:bg>
       <p:bgPr>
@@ -4686,7 +5563,7 @@
       </p:grpSpPr>
       <p:pic>
         <p:nvPicPr>
-          <p:cNvPr id="2" name="Image 0" descr="/agent/turn2/workspace/images/image-8ce9a265a542bcaa91806bc567f2e273.jpg"/>
+          <p:cNvPr id="2" name="Image 0"/>
           <p:cNvPicPr>
             <a:picLocks noChangeAspect="1"/>
           </p:cNvPicPr>
@@ -5620,7 +6497,7 @@
 </p:sld>
 </file>
 
-<file path=ppt/slides/slide4.xml><?xml version="1.0" encoding="utf-8"?>
+<file path=ppt/slides/slide5.xml><?xml version="1.0" encoding="utf-8"?>
 <p:sld xmlns:a="http://schemas.openxmlformats.org/drawingml/2006/main" xmlns:r="http://schemas.openxmlformats.org/officeDocument/2006/relationships" xmlns:p="http://schemas.openxmlformats.org/presentationml/2006/main">
   <p:cSld name="Slide 4">
     <p:bg>
@@ -5647,7 +6524,7 @@
       </p:grpSpPr>
       <p:pic>
         <p:nvPicPr>
-          <p:cNvPr id="2" name="Image 0" descr="/agent/turn2/workspace/images/image-d1b8bd1c7c6f52fed723722a0b172cc0.jpg"/>
+          <p:cNvPr id="2" name="Image 0"/>
           <p:cNvPicPr>
             <a:picLocks noChangeAspect="1"/>
           </p:cNvPicPr>
@@ -6073,7 +6950,7 @@
                   <a:ea typeface="Calibri" pitchFamily="34" charset="-122"/>
                   <a:cs typeface="Calibri" pitchFamily="34" charset="-120"/>
                 </a:rPr>
-                <a:t>Souveraineté du citoyen</a:t>
+                <a:t>Souveraineté du citoyen (RGPD)</a:t>
               </a:r>
               <a:endParaRPr lang="fr-FR" sz="1600" noProof="0" dirty="0"/>
             </a:p>
@@ -6437,7 +7314,7 @@
 </p:sld>
 </file>
 
-<file path=ppt/slides/slide5.xml><?xml version="1.0" encoding="utf-8"?>
+<file path=ppt/slides/slide6.xml><?xml version="1.0" encoding="utf-8"?>
 <p:sld xmlns:a="http://schemas.openxmlformats.org/drawingml/2006/main" xmlns:r="http://schemas.openxmlformats.org/officeDocument/2006/relationships" xmlns:p="http://schemas.openxmlformats.org/presentationml/2006/main">
   <p:cSld name="Slide 5">
     <p:bg>
@@ -7454,7 +8331,7 @@
 </p:sld>
 </file>
 
-<file path=ppt/slides/slide6.xml><?xml version="1.0" encoding="utf-8"?>
+<file path=ppt/slides/slide7.xml><?xml version="1.0" encoding="utf-8"?>
 <p:sld xmlns:a="http://schemas.openxmlformats.org/drawingml/2006/main" xmlns:r="http://schemas.openxmlformats.org/officeDocument/2006/relationships" xmlns:p="http://schemas.openxmlformats.org/presentationml/2006/main">
   <p:cSld name="Slide 6">
     <p:bg>

</xml_diff>